<commit_message>
Release v1.10.0: official site, Office pick, Swarm, App Clip.
vavapp.com now ships paired light/dark shots and download buttons
that always go to GitHub latest. The default product story is VAV
chat with pick-to-ask Office, Mermaid/Vega-Lite in the thread, and
App Clips; Swarm and the Cloudflare/Supabase trays stay behind
settings. Marketing captures match those loops.
</commit_message>
<xml_diff>
--- a/docs/marketing-samples/q3-ops-review.pptx
+++ b/docs/marketing-samples/q3-ops-review.pptx
@@ -1032,13 +1032,6 @@
 <file path=ppt/slides/slide1.xml><?xml version="1.0" encoding="utf-8"?>
 <p:sld xmlns:a="http://schemas.openxmlformats.org/drawingml/2006/main" xmlns:r="http://schemas.openxmlformats.org/officeDocument/2006/relationships" xmlns:p="http://schemas.openxmlformats.org/presentationml/2006/main">
   <p:cSld name="Slide 1">
-    <p:bg>
-      <p:bgPr>
-        <a:solidFill>
-          <a:srgbClr val="F7F6F3"/>
-        </a:solidFill>
-      </p:bgPr>
-    </p:bg>
     <p:spTree>
       <p:nvGrpSpPr>
         <p:cNvPr id="1" name=""/>
@@ -1055,14 +1048,54 @@
       </p:grpSpPr>
       <p:sp>
         <p:nvSpPr>
-          <p:cNvPr id="2" name="Text 0"/>
-          <p:cNvSpPr/>
-          <p:nvPr/>
-        </p:nvSpPr>
-        <p:spPr>
-          <a:xfrm>
-            <a:off x="731520" y="2194560"/>
-            <a:ext cx="10058400" cy="914400"/>
+          <p:cNvPr id="2" name="Shape 0"/>
+          <p:cNvSpPr/>
+          <p:nvPr/>
+        </p:nvSpPr>
+        <p:spPr>
+          <a:xfrm>
+            <a:off x="0" y="0"/>
+            <a:ext cx="12191695" cy="6858000"/>
+          </a:xfrm>
+          <a:prstGeom prst="rect">
+            <a:avLst/>
+          </a:prstGeom>
+          <a:solidFill>
+            <a:srgbClr val="1B1B1D"/>
+          </a:solidFill>
+          <a:ln/>
+        </p:spPr>
+      </p:sp>
+      <p:sp>
+        <p:nvSpPr>
+          <p:cNvPr id="3" name="Shape 1"/>
+          <p:cNvSpPr/>
+          <p:nvPr/>
+        </p:nvSpPr>
+        <p:spPr>
+          <a:xfrm>
+            <a:off x="0" y="0"/>
+            <a:ext cx="128016" cy="6858000"/>
+          </a:xfrm>
+          <a:prstGeom prst="rect">
+            <a:avLst/>
+          </a:prstGeom>
+          <a:solidFill>
+            <a:srgbClr val="B7AAF3"/>
+          </a:solidFill>
+          <a:ln/>
+        </p:spPr>
+      </p:sp>
+      <p:sp>
+        <p:nvSpPr>
+          <p:cNvPr id="4" name="Text 2"/>
+          <p:cNvSpPr/>
+          <p:nvPr/>
+        </p:nvSpPr>
+        <p:spPr>
+          <a:xfrm>
+            <a:off x="822960" y="1691640"/>
+            <a:ext cx="10058400" cy="365760"/>
           </a:xfrm>
           <a:prstGeom prst="rect">
             <a:avLst/>
@@ -1071,16 +1104,55 @@
           <a:ln/>
         </p:spPr>
         <p:txBody>
-          <a:bodyPr wrap="square" rtlCol="0" anchor="ctr"/>
+          <a:bodyPr wrap="square" lIns="0" tIns="0" rIns="0" bIns="0" rtlCol="0" anchor="ctr"/>
           <a:lstStyle/>
           <a:p>
             <a:pPr indent="0" marL="0">
               <a:buNone/>
             </a:pPr>
             <a:r>
-              <a:rPr lang="en-US" sz="4000" b="1" dirty="0">
+              <a:rPr lang="en-US" sz="1400" dirty="0">
                 <a:solidFill>
-                  <a:srgbClr val="1A1A1A"/>
+                  <a:srgbClr val="B7AAF3"/>
+                </a:solidFill>
+                <a:latin typeface="Arial" pitchFamily="34" charset="0"/>
+                <a:ea typeface="Arial" pitchFamily="34" charset="-122"/>
+                <a:cs typeface="Arial" pitchFamily="34" charset="-120"/>
+              </a:rPr>
+              <a:t>Q3  ·  Ops</a:t>
+            </a:r>
+            <a:endParaRPr lang="en-US" sz="1400" dirty="0"/>
+          </a:p>
+        </p:txBody>
+      </p:sp>
+      <p:sp>
+        <p:nvSpPr>
+          <p:cNvPr id="5" name="Text 3"/>
+          <p:cNvSpPr/>
+          <p:nvPr/>
+        </p:nvSpPr>
+        <p:spPr>
+          <a:xfrm>
+            <a:off x="822960" y="2103120"/>
+            <a:ext cx="10241280" cy="960120"/>
+          </a:xfrm>
+          <a:prstGeom prst="rect">
+            <a:avLst/>
+          </a:prstGeom>
+          <a:noFill/>
+          <a:ln/>
+        </p:spPr>
+        <p:txBody>
+          <a:bodyPr wrap="square" lIns="0" tIns="0" rIns="0" bIns="0" rtlCol="0" anchor="ctr"/>
+          <a:lstStyle/>
+          <a:p>
+            <a:pPr indent="0" marL="0">
+              <a:buNone/>
+            </a:pPr>
+            <a:r>
+              <a:rPr lang="en-US" sz="4400" b="1" dirty="0">
+                <a:solidFill>
+                  <a:srgbClr val="EFEFF1"/>
                 </a:solidFill>
                 <a:latin typeface="Arial" pitchFamily="34" charset="0"/>
                 <a:ea typeface="Arial" pitchFamily="34" charset="-122"/>
@@ -1088,19 +1160,19 @@
               </a:rPr>
               <a:t>Q3 ops review</a:t>
             </a:r>
-            <a:endParaRPr lang="en-US" sz="4000" dirty="0"/>
-          </a:p>
-        </p:txBody>
-      </p:sp>
-      <p:sp>
-        <p:nvSpPr>
-          <p:cNvPr id="3" name="Text 1"/>
-          <p:cNvSpPr/>
-          <p:nvPr/>
-        </p:nvSpPr>
-        <p:spPr>
-          <a:xfrm>
-            <a:off x="731520" y="3200400"/>
+            <a:endParaRPr lang="en-US" sz="4400" dirty="0"/>
+          </a:p>
+        </p:txBody>
+      </p:sp>
+      <p:sp>
+        <p:nvSpPr>
+          <p:cNvPr id="6" name="Text 4"/>
+          <p:cNvSpPr/>
+          <p:nvPr/>
+        </p:nvSpPr>
+        <p:spPr>
+          <a:xfrm>
+            <a:off x="822960" y="3154680"/>
             <a:ext cx="9144000" cy="457200"/>
           </a:xfrm>
           <a:prstGeom prst="rect">
@@ -1110,7 +1182,7 @@
           <a:ln/>
         </p:spPr>
         <p:txBody>
-          <a:bodyPr wrap="square" rtlCol="0" anchor="ctr"/>
+          <a:bodyPr wrap="square" lIns="0" tIns="0" rIns="0" bIns="0" rtlCol="0" anchor="ctr"/>
           <a:lstStyle/>
           <a:p>
             <a:pPr indent="0" marL="0">
@@ -1119,15 +1191,54 @@
             <a:r>
               <a:rPr lang="en-US" sz="1800" dirty="0">
                 <a:solidFill>
-                  <a:srgbClr val="555555"/>
+                  <a:srgbClr val="A2A2A9"/>
                 </a:solidFill>
                 <a:latin typeface="Arial" pitchFamily="34" charset="0"/>
                 <a:ea typeface="Arial" pitchFamily="34" charset="-122"/>
                 <a:cs typeface="Arial" pitchFamily="34" charset="-120"/>
               </a:rPr>
-              <a:t>APAC led shipped revenue · restock focus for AMER / EMEA</a:t>
+              <a:t>APAC led shipped revenue. Restock focus for AMER and EMEA.</a:t>
             </a:r>
             <a:endParaRPr lang="en-US" sz="1800" dirty="0"/>
+          </a:p>
+        </p:txBody>
+      </p:sp>
+      <p:sp>
+        <p:nvSpPr>
+          <p:cNvPr id="7" name="Text 5"/>
+          <p:cNvSpPr/>
+          <p:nvPr/>
+        </p:nvSpPr>
+        <p:spPr>
+          <a:xfrm>
+            <a:off x="822960" y="6126480"/>
+            <a:ext cx="7315200" cy="274320"/>
+          </a:xfrm>
+          <a:prstGeom prst="rect">
+            <a:avLst/>
+          </a:prstGeom>
+          <a:noFill/>
+          <a:ln/>
+        </p:spPr>
+        <p:txBody>
+          <a:bodyPr wrap="square" lIns="0" tIns="0" rIns="0" bIns="0" rtlCol="0" anchor="ctr"/>
+          <a:lstStyle/>
+          <a:p>
+            <a:pPr indent="0" marL="0">
+              <a:buNone/>
+            </a:pPr>
+            <a:r>
+              <a:rPr lang="en-US" sz="1200" dirty="0">
+                <a:solidFill>
+                  <a:srgbClr val="73737B"/>
+                </a:solidFill>
+                <a:latin typeface="Arial" pitchFamily="34" charset="0"/>
+                <a:ea typeface="Arial" pitchFamily="34" charset="-122"/>
+                <a:cs typeface="Arial" pitchFamily="34" charset="-120"/>
+              </a:rPr>
+              <a:t>Internal  ·  12 min  ·  Three slides</a:t>
+            </a:r>
+            <a:endParaRPr lang="en-US" sz="1200" dirty="0"/>
           </a:p>
         </p:txBody>
       </p:sp>
@@ -1142,13 +1253,6 @@
 <file path=ppt/slides/slide2.xml><?xml version="1.0" encoding="utf-8"?>
 <p:sld xmlns:a="http://schemas.openxmlformats.org/drawingml/2006/main" xmlns:r="http://schemas.openxmlformats.org/officeDocument/2006/relationships" xmlns:p="http://schemas.openxmlformats.org/presentationml/2006/main">
   <p:cSld name="Slide 2">
-    <p:bg>
-      <p:bgPr>
-        <a:solidFill>
-          <a:srgbClr val="F7F6F3"/>
-        </a:solidFill>
-      </p:bgPr>
-    </p:bg>
     <p:spTree>
       <p:nvGrpSpPr>
         <p:cNvPr id="1" name=""/>
@@ -1165,14 +1269,34 @@
       </p:grpSpPr>
       <p:sp>
         <p:nvSpPr>
-          <p:cNvPr id="2" name="Text 0"/>
-          <p:cNvSpPr/>
-          <p:nvPr/>
-        </p:nvSpPr>
-        <p:spPr>
-          <a:xfrm>
-            <a:off x="731520" y="548640"/>
-            <a:ext cx="9144000" cy="548640"/>
+          <p:cNvPr id="2" name="Shape 0"/>
+          <p:cNvSpPr/>
+          <p:nvPr/>
+        </p:nvSpPr>
+        <p:spPr>
+          <a:xfrm>
+            <a:off x="0" y="0"/>
+            <a:ext cx="12191695" cy="6858000"/>
+          </a:xfrm>
+          <a:prstGeom prst="rect">
+            <a:avLst/>
+          </a:prstGeom>
+          <a:solidFill>
+            <a:srgbClr val="1B1B1D"/>
+          </a:solidFill>
+          <a:ln/>
+        </p:spPr>
+      </p:sp>
+      <p:sp>
+        <p:nvSpPr>
+          <p:cNvPr id="3" name="Text 1"/>
+          <p:cNvSpPr/>
+          <p:nvPr/>
+        </p:nvSpPr>
+        <p:spPr>
+          <a:xfrm>
+            <a:off x="640080" y="347472"/>
+            <a:ext cx="9144000" cy="640080"/>
           </a:xfrm>
           <a:prstGeom prst="rect">
             <a:avLst/>
@@ -1181,37 +1305,37 @@
           <a:ln/>
         </p:spPr>
         <p:txBody>
-          <a:bodyPr wrap="square" rtlCol="0" anchor="ctr"/>
+          <a:bodyPr wrap="square" lIns="0" tIns="0" rIns="0" bIns="0" rtlCol="0" anchor="ctr"/>
           <a:lstStyle/>
           <a:p>
             <a:pPr indent="0" marL="0">
               <a:buNone/>
             </a:pPr>
             <a:r>
-              <a:rPr lang="en-US" sz="2800" b="1" dirty="0">
+              <a:rPr lang="en-US" sz="3200" b="1" dirty="0">
                 <a:solidFill>
-                  <a:srgbClr val="1A1A1A"/>
+                  <a:srgbClr val="EFEFF1"/>
                 </a:solidFill>
                 <a:latin typeface="Arial" pitchFamily="34" charset="0"/>
                 <a:ea typeface="Arial" pitchFamily="34" charset="-122"/>
                 <a:cs typeface="Arial" pitchFamily="34" charset="-120"/>
               </a:rPr>
-              <a:t>Highlights</a:t>
-            </a:r>
-            <a:endParaRPr lang="en-US" sz="2800" dirty="0"/>
-          </a:p>
-        </p:txBody>
-      </p:sp>
-      <p:sp>
-        <p:nvSpPr>
-          <p:cNvPr id="3" name="Text 1"/>
-          <p:cNvSpPr/>
-          <p:nvPr/>
-        </p:nvSpPr>
-        <p:spPr>
-          <a:xfrm>
-            <a:off x="731520" y="1463040"/>
-            <a:ext cx="10058400" cy="2743200"/>
+              <a:t>Where we’re blocked</a:t>
+            </a:r>
+            <a:endParaRPr lang="en-US" sz="3200" dirty="0"/>
+          </a:p>
+        </p:txBody>
+      </p:sp>
+      <p:sp>
+        <p:nvSpPr>
+          <p:cNvPr id="4" name="Text 2"/>
+          <p:cNvSpPr/>
+          <p:nvPr/>
+        </p:nvSpPr>
+        <p:spPr>
+          <a:xfrm>
+            <a:off x="640080" y="987552"/>
+            <a:ext cx="10058400" cy="320040"/>
           </a:xfrm>
           <a:prstGeom prst="rect">
             <a:avLst/>
@@ -1220,67 +1344,528 @@
           <a:ln/>
         </p:spPr>
         <p:txBody>
-          <a:bodyPr wrap="square" rtlCol="0" anchor="ctr"/>
+          <a:bodyPr wrap="square" lIns="0" tIns="0" rIns="0" bIns="0" rtlCol="0" anchor="ctr"/>
           <a:lstStyle/>
           <a:p>
             <a:pPr indent="0" marL="0">
-              <a:spcAft>
-                <a:spcPts val="1200"/>
-              </a:spcAft>
               <a:buNone/>
             </a:pPr>
             <a:r>
-              <a:rPr lang="en-US" sz="2000" dirty="0">
+              <a:rPr lang="en-US" sz="1400" dirty="0">
                 <a:solidFill>
-                  <a:srgbClr val="333333"/>
+                  <a:srgbClr val="A2A2A9"/>
                 </a:solidFill>
                 <a:latin typeface="Arial" pitchFamily="34" charset="0"/>
                 <a:ea typeface="Arial" pitchFamily="34" charset="-122"/>
                 <a:cs typeface="Arial" pitchFamily="34" charset="-120"/>
               </a:rPr>
-              <a:t>APAC shipped ~$31k across WIDGET-A/B</a:t>
-            </a:r>
-            <a:endParaRPr lang="en-US" sz="2000" dirty="0"/>
-          </a:p>
-          <a:p>
-            <a:pPr indent="0" marL="0">
-              <a:spcAft>
-                <a:spcPts val="1200"/>
-              </a:spcAft>
+              <a:t>Pick a card — the agent edits the same .pptx on disk.</a:t>
+            </a:r>
+            <a:endParaRPr lang="en-US" sz="1400" dirty="0"/>
+          </a:p>
+        </p:txBody>
+      </p:sp>
+      <p:sp>
+        <p:nvSpPr>
+          <p:cNvPr id="5" name="Shape 3"/>
+          <p:cNvSpPr/>
+          <p:nvPr/>
+        </p:nvSpPr>
+        <p:spPr>
+          <a:xfrm>
+            <a:off x="640080" y="1554480"/>
+            <a:ext cx="3520440" cy="4114800"/>
+          </a:xfrm>
+          <a:prstGeom prst="roundRect">
+            <a:avLst>
+              <a:gd name="adj" fmla="val 3117"/>
+            </a:avLst>
+          </a:prstGeom>
+          <a:solidFill>
+            <a:srgbClr val="242427"/>
+          </a:solidFill>
+          <a:ln/>
+          <a:effectLst>
+            <a:outerShdw sx="100000" sy="100000" kx="0" ky="0" algn="bl" rotWithShape="0" blurRad="152400" dist="25400" dir="16200000">
+              <a:srgbClr val="141416">
+                <a:alpha val="8000"/>
+              </a:srgbClr>
+            </a:outerShdw>
+          </a:effectLst>
+        </p:spPr>
+      </p:sp>
+      <p:sp>
+        <p:nvSpPr>
+          <p:cNvPr id="6" name="Shape 4"/>
+          <p:cNvSpPr/>
+          <p:nvPr/>
+        </p:nvSpPr>
+        <p:spPr>
+          <a:xfrm>
+            <a:off x="896112" y="1828800"/>
+            <a:ext cx="1234440" cy="292608"/>
+          </a:xfrm>
+          <a:prstGeom prst="roundRect">
+            <a:avLst>
+              <a:gd name="adj" fmla="val 18750"/>
+            </a:avLst>
+          </a:prstGeom>
+          <a:solidFill>
+            <a:srgbClr val="E8817C"/>
+          </a:solidFill>
+          <a:ln/>
+        </p:spPr>
+      </p:sp>
+      <p:sp>
+        <p:nvSpPr>
+          <p:cNvPr id="7" name="Text 5"/>
+          <p:cNvSpPr/>
+          <p:nvPr/>
+        </p:nvSpPr>
+        <p:spPr>
+          <a:xfrm>
+            <a:off x="896112" y="1828800"/>
+            <a:ext cx="1234440" cy="292608"/>
+          </a:xfrm>
+          <a:prstGeom prst="rect">
+            <a:avLst/>
+          </a:prstGeom>
+          <a:noFill/>
+          <a:ln/>
+        </p:spPr>
+        <p:txBody>
+          <a:bodyPr wrap="square" lIns="0" tIns="0" rIns="0" bIns="0" rtlCol="0" anchor="ctr"/>
+          <a:lstStyle/>
+          <a:p>
+            <a:pPr algn="ctr" indent="0" marL="0">
               <a:buNone/>
             </a:pPr>
             <a:r>
-              <a:rPr lang="en-US" sz="2000" dirty="0">
+              <a:rPr lang="en-US" sz="1100" b="1" dirty="0">
                 <a:solidFill>
-                  <a:srgbClr val="333333"/>
+                  <a:srgbClr val="141416"/>
                 </a:solidFill>
                 <a:latin typeface="Arial" pitchFamily="34" charset="0"/>
                 <a:ea typeface="Arial" pitchFamily="34" charset="-122"/>
                 <a:cs typeface="Arial" pitchFamily="34" charset="-120"/>
               </a:rPr>
-              <a:t>Pending: AMER WIDGET-A (200) · EMEA WIDGET-C (22)</a:t>
-            </a:r>
-            <a:endParaRPr lang="en-US" sz="2000" dirty="0"/>
-          </a:p>
+              <a:t>Blocker</a:t>
+            </a:r>
+            <a:endParaRPr lang="en-US" sz="1100" dirty="0"/>
+          </a:p>
+        </p:txBody>
+      </p:sp>
+      <p:sp>
+        <p:nvSpPr>
+          <p:cNvPr id="8" name="Text 6"/>
+          <p:cNvSpPr/>
+          <p:nvPr/>
+        </p:nvSpPr>
+        <p:spPr>
+          <a:xfrm>
+            <a:off x="896112" y="2331720"/>
+            <a:ext cx="3017520" cy="777240"/>
+          </a:xfrm>
+          <a:prstGeom prst="rect">
+            <a:avLst/>
+          </a:prstGeom>
+          <a:noFill/>
+          <a:ln/>
+        </p:spPr>
+        <p:txBody>
+          <a:bodyPr wrap="square" lIns="0" tIns="0" rIns="0" bIns="0" rtlCol="0" anchor="ctr"/>
+          <a:lstStyle/>
           <a:p>
             <a:pPr indent="0" marL="0">
-              <a:spcAft>
-                <a:spcPts val="1200"/>
-              </a:spcAft>
               <a:buNone/>
             </a:pPr>
             <a:r>
-              <a:rPr lang="en-US" sz="2000" dirty="0">
+              <a:rPr lang="en-US" sz="2200" b="1" dirty="0">
                 <a:solidFill>
-                  <a:srgbClr val="333333"/>
+                  <a:srgbClr val="EFEFF1"/>
                 </a:solidFill>
                 <a:latin typeface="Arial" pitchFamily="34" charset="0"/>
                 <a:ea typeface="Arial" pitchFamily="34" charset="-122"/>
                 <a:cs typeface="Arial" pitchFamily="34" charset="-120"/>
               </a:rPr>
-              <a:t>One cancelled AMER WIDGET-B — exclude from fulfillment</a:t>
-            </a:r>
-            <a:endParaRPr lang="en-US" sz="2000" dirty="0"/>
+              <a:t>AMER restock</a:t>
+            </a:r>
+            <a:endParaRPr lang="en-US" sz="2200" dirty="0"/>
+          </a:p>
+        </p:txBody>
+      </p:sp>
+      <p:sp>
+        <p:nvSpPr>
+          <p:cNvPr id="9" name="Text 7"/>
+          <p:cNvSpPr/>
+          <p:nvPr/>
+        </p:nvSpPr>
+        <p:spPr>
+          <a:xfrm>
+            <a:off x="896112" y="3200400"/>
+            <a:ext cx="3017520" cy="1645920"/>
+          </a:xfrm>
+          <a:prstGeom prst="rect">
+            <a:avLst/>
+          </a:prstGeom>
+          <a:noFill/>
+          <a:ln/>
+        </p:spPr>
+        <p:txBody>
+          <a:bodyPr wrap="square" lIns="0" tIns="0" rIns="0" bIns="0" rtlCol="0" anchor="ctr"/>
+          <a:lstStyle/>
+          <a:p>
+            <a:pPr indent="0" marL="0">
+              <a:buNone/>
+            </a:pPr>
+            <a:r>
+              <a:rPr lang="en-US" sz="1500" dirty="0">
+                <a:solidFill>
+                  <a:srgbClr val="A2A2A9"/>
+                </a:solidFill>
+                <a:latin typeface="Arial" pitchFamily="34" charset="0"/>
+                <a:ea typeface="Arial" pitchFamily="34" charset="-122"/>
+                <a:cs typeface="Arial" pitchFamily="34" charset="-120"/>
+              </a:rPr>
+              <a:t>WIDGET-A × 200 still pending warehouse confirm.</a:t>
+            </a:r>
+            <a:endParaRPr lang="en-US" sz="1500" dirty="0"/>
+          </a:p>
+        </p:txBody>
+      </p:sp>
+      <p:sp>
+        <p:nvSpPr>
+          <p:cNvPr id="10" name="Shape 8"/>
+          <p:cNvSpPr/>
+          <p:nvPr/>
+        </p:nvSpPr>
+        <p:spPr>
+          <a:xfrm>
+            <a:off x="4389120" y="1554480"/>
+            <a:ext cx="3520440" cy="4114800"/>
+          </a:xfrm>
+          <a:prstGeom prst="roundRect">
+            <a:avLst>
+              <a:gd name="adj" fmla="val 3117"/>
+            </a:avLst>
+          </a:prstGeom>
+          <a:solidFill>
+            <a:srgbClr val="242427"/>
+          </a:solidFill>
+          <a:ln/>
+          <a:effectLst>
+            <a:outerShdw sx="100000" sy="100000" kx="0" ky="0" algn="bl" rotWithShape="0" blurRad="152400" dist="25400" dir="16200000">
+              <a:srgbClr val="141416">
+                <a:alpha val="8000"/>
+              </a:srgbClr>
+            </a:outerShdw>
+          </a:effectLst>
+        </p:spPr>
+      </p:sp>
+      <p:sp>
+        <p:nvSpPr>
+          <p:cNvPr id="11" name="Shape 9"/>
+          <p:cNvSpPr/>
+          <p:nvPr/>
+        </p:nvSpPr>
+        <p:spPr>
+          <a:xfrm>
+            <a:off x="4645152" y="1828800"/>
+            <a:ext cx="1234440" cy="292608"/>
+          </a:xfrm>
+          <a:prstGeom prst="roundRect">
+            <a:avLst>
+              <a:gd name="adj" fmla="val 18750"/>
+            </a:avLst>
+          </a:prstGeom>
+          <a:solidFill>
+            <a:srgbClr val="D8AC62"/>
+          </a:solidFill>
+          <a:ln/>
+        </p:spPr>
+      </p:sp>
+      <p:sp>
+        <p:nvSpPr>
+          <p:cNvPr id="12" name="Text 10"/>
+          <p:cNvSpPr/>
+          <p:nvPr/>
+        </p:nvSpPr>
+        <p:spPr>
+          <a:xfrm>
+            <a:off x="4645152" y="1828800"/>
+            <a:ext cx="1234440" cy="292608"/>
+          </a:xfrm>
+          <a:prstGeom prst="rect">
+            <a:avLst/>
+          </a:prstGeom>
+          <a:noFill/>
+          <a:ln/>
+        </p:spPr>
+        <p:txBody>
+          <a:bodyPr wrap="square" lIns="0" tIns="0" rIns="0" bIns="0" rtlCol="0" anchor="ctr"/>
+          <a:lstStyle/>
+          <a:p>
+            <a:pPr algn="ctr" indent="0" marL="0">
+              <a:buNone/>
+            </a:pPr>
+            <a:r>
+              <a:rPr lang="en-US" sz="1100" b="1" dirty="0">
+                <a:solidFill>
+                  <a:srgbClr val="141416"/>
+                </a:solidFill>
+                <a:latin typeface="Arial" pitchFamily="34" charset="0"/>
+                <a:ea typeface="Arial" pitchFamily="34" charset="-122"/>
+                <a:cs typeface="Arial" pitchFamily="34" charset="-120"/>
+              </a:rPr>
+              <a:t>Decide</a:t>
+            </a:r>
+            <a:endParaRPr lang="en-US" sz="1100" dirty="0"/>
+          </a:p>
+        </p:txBody>
+      </p:sp>
+      <p:sp>
+        <p:nvSpPr>
+          <p:cNvPr id="13" name="Text 11"/>
+          <p:cNvSpPr/>
+          <p:nvPr/>
+        </p:nvSpPr>
+        <p:spPr>
+          <a:xfrm>
+            <a:off x="4645152" y="2331720"/>
+            <a:ext cx="3017520" cy="777240"/>
+          </a:xfrm>
+          <a:prstGeom prst="rect">
+            <a:avLst/>
+          </a:prstGeom>
+          <a:noFill/>
+          <a:ln/>
+        </p:spPr>
+        <p:txBody>
+          <a:bodyPr wrap="square" lIns="0" tIns="0" rIns="0" bIns="0" rtlCol="0" anchor="ctr"/>
+          <a:lstStyle/>
+          <a:p>
+            <a:pPr indent="0" marL="0">
+              <a:buNone/>
+            </a:pPr>
+            <a:r>
+              <a:rPr lang="en-US" sz="2200" b="1" dirty="0">
+                <a:solidFill>
+                  <a:srgbClr val="EFEFF1"/>
+                </a:solidFill>
+                <a:latin typeface="Arial" pitchFamily="34" charset="0"/>
+                <a:ea typeface="Arial" pitchFamily="34" charset="-122"/>
+                <a:cs typeface="Arial" pitchFamily="34" charset="-120"/>
+              </a:rPr>
+              <a:t>EMEA WIDGET-C</a:t>
+            </a:r>
+            <a:endParaRPr lang="en-US" sz="2200" dirty="0"/>
+          </a:p>
+        </p:txBody>
+      </p:sp>
+      <p:sp>
+        <p:nvSpPr>
+          <p:cNvPr id="14" name="Text 12"/>
+          <p:cNvSpPr/>
+          <p:nvPr/>
+        </p:nvSpPr>
+        <p:spPr>
+          <a:xfrm>
+            <a:off x="4645152" y="3200400"/>
+            <a:ext cx="3017520" cy="1645920"/>
+          </a:xfrm>
+          <a:prstGeom prst="rect">
+            <a:avLst/>
+          </a:prstGeom>
+          <a:noFill/>
+          <a:ln/>
+        </p:spPr>
+        <p:txBody>
+          <a:bodyPr wrap="square" lIns="0" tIns="0" rIns="0" bIns="0" rtlCol="0" anchor="ctr"/>
+          <a:lstStyle/>
+          <a:p>
+            <a:pPr indent="0" marL="0">
+              <a:buNone/>
+            </a:pPr>
+            <a:r>
+              <a:rPr lang="en-US" sz="1500" dirty="0">
+                <a:solidFill>
+                  <a:srgbClr val="A2A2A9"/>
+                </a:solidFill>
+                <a:latin typeface="Arial" pitchFamily="34" charset="0"/>
+                <a:ea typeface="Arial" pitchFamily="34" charset="-122"/>
+                <a:cs typeface="Arial" pitchFamily="34" charset="-120"/>
+              </a:rPr>
+              <a:t>22 units — expedite this week or drop from the Q3 target.</a:t>
+            </a:r>
+            <a:endParaRPr lang="en-US" sz="1500" dirty="0"/>
+          </a:p>
+        </p:txBody>
+      </p:sp>
+      <p:sp>
+        <p:nvSpPr>
+          <p:cNvPr id="15" name="Shape 13"/>
+          <p:cNvSpPr/>
+          <p:nvPr/>
+        </p:nvSpPr>
+        <p:spPr>
+          <a:xfrm>
+            <a:off x="8138160" y="1554480"/>
+            <a:ext cx="3520440" cy="4114800"/>
+          </a:xfrm>
+          <a:prstGeom prst="roundRect">
+            <a:avLst>
+              <a:gd name="adj" fmla="val 3117"/>
+            </a:avLst>
+          </a:prstGeom>
+          <a:solidFill>
+            <a:srgbClr val="242427"/>
+          </a:solidFill>
+          <a:ln/>
+          <a:effectLst>
+            <a:outerShdw sx="100000" sy="100000" kx="0" ky="0" algn="bl" rotWithShape="0" blurRad="152400" dist="25400" dir="16200000">
+              <a:srgbClr val="141416">
+                <a:alpha val="8000"/>
+              </a:srgbClr>
+            </a:outerShdw>
+          </a:effectLst>
+        </p:spPr>
+      </p:sp>
+      <p:sp>
+        <p:nvSpPr>
+          <p:cNvPr id="16" name="Shape 14"/>
+          <p:cNvSpPr/>
+          <p:nvPr/>
+        </p:nvSpPr>
+        <p:spPr>
+          <a:xfrm>
+            <a:off x="8394192" y="1828800"/>
+            <a:ext cx="1234440" cy="292608"/>
+          </a:xfrm>
+          <a:prstGeom prst="roundRect">
+            <a:avLst>
+              <a:gd name="adj" fmla="val 18750"/>
+            </a:avLst>
+          </a:prstGeom>
+          <a:solidFill>
+            <a:srgbClr val="B7AAF3"/>
+          </a:solidFill>
+          <a:ln/>
+        </p:spPr>
+      </p:sp>
+      <p:sp>
+        <p:nvSpPr>
+          <p:cNvPr id="17" name="Text 15"/>
+          <p:cNvSpPr/>
+          <p:nvPr/>
+        </p:nvSpPr>
+        <p:spPr>
+          <a:xfrm>
+            <a:off x="8394192" y="1828800"/>
+            <a:ext cx="1234440" cy="292608"/>
+          </a:xfrm>
+          <a:prstGeom prst="rect">
+            <a:avLst/>
+          </a:prstGeom>
+          <a:noFill/>
+          <a:ln/>
+        </p:spPr>
+        <p:txBody>
+          <a:bodyPr wrap="square" lIns="0" tIns="0" rIns="0" bIns="0" rtlCol="0" anchor="ctr"/>
+          <a:lstStyle/>
+          <a:p>
+            <a:pPr algn="ctr" indent="0" marL="0">
+              <a:buNone/>
+            </a:pPr>
+            <a:r>
+              <a:rPr lang="en-US" sz="1100" b="1" dirty="0">
+                <a:solidFill>
+                  <a:srgbClr val="141416"/>
+                </a:solidFill>
+                <a:latin typeface="Arial" pitchFamily="34" charset="0"/>
+                <a:ea typeface="Arial" pitchFamily="34" charset="-122"/>
+                <a:cs typeface="Arial" pitchFamily="34" charset="-120"/>
+              </a:rPr>
+              <a:t>Hygiene</a:t>
+            </a:r>
+            <a:endParaRPr lang="en-US" sz="1100" dirty="0"/>
+          </a:p>
+        </p:txBody>
+      </p:sp>
+      <p:sp>
+        <p:nvSpPr>
+          <p:cNvPr id="18" name="Text 16"/>
+          <p:cNvSpPr/>
+          <p:nvPr/>
+        </p:nvSpPr>
+        <p:spPr>
+          <a:xfrm>
+            <a:off x="8394192" y="2331720"/>
+            <a:ext cx="3017520" cy="777240"/>
+          </a:xfrm>
+          <a:prstGeom prst="rect">
+            <a:avLst/>
+          </a:prstGeom>
+          <a:noFill/>
+          <a:ln/>
+        </p:spPr>
+        <p:txBody>
+          <a:bodyPr wrap="square" lIns="0" tIns="0" rIns="0" bIns="0" rtlCol="0" anchor="ctr"/>
+          <a:lstStyle/>
+          <a:p>
+            <a:pPr indent="0" marL="0">
+              <a:buNone/>
+            </a:pPr>
+            <a:r>
+              <a:rPr lang="en-US" sz="2200" b="1" dirty="0">
+                <a:solidFill>
+                  <a:srgbClr val="EFEFF1"/>
+                </a:solidFill>
+                <a:latin typeface="Arial" pitchFamily="34" charset="0"/>
+                <a:ea typeface="Arial" pitchFamily="34" charset="-122"/>
+                <a:cs typeface="Arial" pitchFamily="34" charset="-120"/>
+              </a:rPr>
+              <a:t>Cancelled noise</a:t>
+            </a:r>
+            <a:endParaRPr lang="en-US" sz="2200" dirty="0"/>
+          </a:p>
+        </p:txBody>
+      </p:sp>
+      <p:sp>
+        <p:nvSpPr>
+          <p:cNvPr id="19" name="Text 17"/>
+          <p:cNvSpPr/>
+          <p:nvPr/>
+        </p:nvSpPr>
+        <p:spPr>
+          <a:xfrm>
+            <a:off x="8394192" y="3200400"/>
+            <a:ext cx="3017520" cy="1645920"/>
+          </a:xfrm>
+          <a:prstGeom prst="rect">
+            <a:avLst/>
+          </a:prstGeom>
+          <a:noFill/>
+          <a:ln/>
+        </p:spPr>
+        <p:txBody>
+          <a:bodyPr wrap="square" lIns="0" tIns="0" rIns="0" bIns="0" rtlCol="0" anchor="ctr"/>
+          <a:lstStyle/>
+          <a:p>
+            <a:pPr indent="0" marL="0">
+              <a:buNone/>
+            </a:pPr>
+            <a:r>
+              <a:rPr lang="en-US" sz="1500" dirty="0">
+                <a:solidFill>
+                  <a:srgbClr val="A2A2A9"/>
+                </a:solidFill>
+                <a:latin typeface="Arial" pitchFamily="34" charset="0"/>
+                <a:ea typeface="Arial" pitchFamily="34" charset="-122"/>
+                <a:cs typeface="Arial" pitchFamily="34" charset="-120"/>
+              </a:rPr>
+              <a:t>AMER WIDGET-B is cancelled. Keep it out of fulfillment totals.</a:t>
+            </a:r>
+            <a:endParaRPr lang="en-US" sz="1500" dirty="0"/>
           </a:p>
         </p:txBody>
       </p:sp>
@@ -1295,13 +1880,6 @@
 <file path=ppt/slides/slide3.xml><?xml version="1.0" encoding="utf-8"?>
 <p:sld xmlns:a="http://schemas.openxmlformats.org/drawingml/2006/main" xmlns:r="http://schemas.openxmlformats.org/officeDocument/2006/relationships" xmlns:p="http://schemas.openxmlformats.org/presentationml/2006/main">
   <p:cSld name="Slide 3">
-    <p:bg>
-      <p:bgPr>
-        <a:solidFill>
-          <a:srgbClr val="F7F6F3"/>
-        </a:solidFill>
-      </p:bgPr>
-    </p:bg>
     <p:spTree>
       <p:nvGrpSpPr>
         <p:cNvPr id="1" name=""/>
@@ -1318,14 +1896,34 @@
       </p:grpSpPr>
       <p:sp>
         <p:nvSpPr>
-          <p:cNvPr id="2" name="Text 0"/>
-          <p:cNvSpPr/>
-          <p:nvPr/>
-        </p:nvSpPr>
-        <p:spPr>
-          <a:xfrm>
-            <a:off x="731520" y="548640"/>
-            <a:ext cx="9144000" cy="548640"/>
+          <p:cNvPr id="2" name="Shape 0"/>
+          <p:cNvSpPr/>
+          <p:nvPr/>
+        </p:nvSpPr>
+        <p:spPr>
+          <a:xfrm>
+            <a:off x="0" y="0"/>
+            <a:ext cx="12191695" cy="6858000"/>
+          </a:xfrm>
+          <a:prstGeom prst="rect">
+            <a:avLst/>
+          </a:prstGeom>
+          <a:solidFill>
+            <a:srgbClr val="1B1B1D"/>
+          </a:solidFill>
+          <a:ln/>
+        </p:spPr>
+      </p:sp>
+      <p:sp>
+        <p:nvSpPr>
+          <p:cNvPr id="3" name="Text 1"/>
+          <p:cNvSpPr/>
+          <p:nvPr/>
+        </p:nvSpPr>
+        <p:spPr>
+          <a:xfrm>
+            <a:off x="731520" y="411480"/>
+            <a:ext cx="9144000" cy="594360"/>
           </a:xfrm>
           <a:prstGeom prst="rect">
             <a:avLst/>
@@ -1334,37 +1932,84 @@
           <a:ln/>
         </p:spPr>
         <p:txBody>
-          <a:bodyPr wrap="square" rtlCol="0" anchor="ctr"/>
+          <a:bodyPr wrap="square" lIns="0" tIns="0" rIns="0" bIns="0" rtlCol="0" anchor="ctr"/>
           <a:lstStyle/>
           <a:p>
             <a:pPr indent="0" marL="0">
               <a:buNone/>
             </a:pPr>
             <a:r>
-              <a:rPr lang="en-US" sz="2800" b="1" dirty="0">
+              <a:rPr lang="en-US" sz="3200" b="1" dirty="0">
                 <a:solidFill>
-                  <a:srgbClr val="1A1A1A"/>
+                  <a:srgbClr val="EFEFF1"/>
                 </a:solidFill>
                 <a:latin typeface="Arial" pitchFamily="34" charset="0"/>
                 <a:ea typeface="Arial" pitchFamily="34" charset="-122"/>
                 <a:cs typeface="Arial" pitchFamily="34" charset="-120"/>
               </a:rPr>
-              <a:t>Ask vav next</a:t>
-            </a:r>
-            <a:endParaRPr lang="en-US" sz="2800" dirty="0"/>
-          </a:p>
-        </p:txBody>
-      </p:sp>
-      <p:sp>
-        <p:nvSpPr>
-          <p:cNvPr id="3" name="Text 1"/>
-          <p:cNvSpPr/>
-          <p:nvPr/>
-        </p:nvSpPr>
-        <p:spPr>
-          <a:xfrm>
-            <a:off x="731520" y="1645920"/>
-            <a:ext cx="10058400" cy="1828800"/>
+              <a:t>Next 7 days</a:t>
+            </a:r>
+            <a:endParaRPr lang="en-US" sz="3200" dirty="0"/>
+          </a:p>
+        </p:txBody>
+      </p:sp>
+      <p:sp>
+        <p:nvSpPr>
+          <p:cNvPr id="4" name="Shape 2"/>
+          <p:cNvSpPr/>
+          <p:nvPr/>
+        </p:nvSpPr>
+        <p:spPr>
+          <a:xfrm>
+            <a:off x="731520" y="1371600"/>
+            <a:ext cx="10698480" cy="914400"/>
+          </a:xfrm>
+          <a:prstGeom prst="roundRect">
+            <a:avLst>
+              <a:gd name="adj" fmla="val 8000"/>
+            </a:avLst>
+          </a:prstGeom>
+          <a:solidFill>
+            <a:srgbClr val="242427"/>
+          </a:solidFill>
+          <a:ln w="12700">
+            <a:solidFill>
+              <a:srgbClr val="3A3A40"/>
+            </a:solidFill>
+            <a:prstDash val="solid"/>
+          </a:ln>
+        </p:spPr>
+      </p:sp>
+      <p:sp>
+        <p:nvSpPr>
+          <p:cNvPr id="5" name="Shape 3"/>
+          <p:cNvSpPr/>
+          <p:nvPr/>
+        </p:nvSpPr>
+        <p:spPr>
+          <a:xfrm>
+            <a:off x="960120" y="1627632"/>
+            <a:ext cx="402336" cy="402336"/>
+          </a:xfrm>
+          <a:prstGeom prst="ellipse">
+            <a:avLst/>
+          </a:prstGeom>
+          <a:solidFill>
+            <a:srgbClr val="B7AAF3"/>
+          </a:solidFill>
+          <a:ln/>
+        </p:spPr>
+      </p:sp>
+      <p:sp>
+        <p:nvSpPr>
+          <p:cNvPr id="6" name="Text 4"/>
+          <p:cNvSpPr/>
+          <p:nvPr/>
+        </p:nvSpPr>
+        <p:spPr>
+          <a:xfrm>
+            <a:off x="960120" y="1627632"/>
+            <a:ext cx="402336" cy="402336"/>
           </a:xfrm>
           <a:prstGeom prst="rect">
             <a:avLst/>
@@ -1373,24 +2018,438 @@
           <a:ln/>
         </p:spPr>
         <p:txBody>
-          <a:bodyPr wrap="square" rtlCol="0" anchor="ctr"/>
-          <a:lstStyle/>
-          <a:p>
-            <a:pPr indent="0" marL="0">
+          <a:bodyPr wrap="square" lIns="0" tIns="0" rIns="0" bIns="0" rtlCol="0" anchor="ctr"/>
+          <a:lstStyle/>
+          <a:p>
+            <a:pPr algn="ctr" indent="0" marL="0">
               <a:buNone/>
             </a:pPr>
             <a:r>
-              <a:rPr lang="en-US" sz="2000" dirty="0">
+              <a:rPr lang="en-US" sz="1400" b="1" dirty="0">
                 <a:solidFill>
-                  <a:srgbClr val="333333"/>
+                  <a:srgbClr val="141416"/>
                 </a:solidFill>
                 <a:latin typeface="Arial" pitchFamily="34" charset="0"/>
                 <a:ea typeface="Arial" pitchFamily="34" charset="-122"/>
                 <a:cs typeface="Arial" pitchFamily="34" charset="-120"/>
               </a:rPr>
-              <a:t>Open the workbook beside the deck — select a region, ask for a restock list, export a PDF brief.</a:t>
-            </a:r>
-            <a:endParaRPr lang="en-US" sz="2000" dirty="0"/>
+              <a:t>1</a:t>
+            </a:r>
+            <a:endParaRPr lang="en-US" sz="1400" dirty="0"/>
+          </a:p>
+        </p:txBody>
+      </p:sp>
+      <p:sp>
+        <p:nvSpPr>
+          <p:cNvPr id="7" name="Text 5"/>
+          <p:cNvSpPr/>
+          <p:nvPr/>
+        </p:nvSpPr>
+        <p:spPr>
+          <a:xfrm>
+            <a:off x="1554480" y="1572768"/>
+            <a:ext cx="9509760" cy="512064"/>
+          </a:xfrm>
+          <a:prstGeom prst="rect">
+            <a:avLst/>
+          </a:prstGeom>
+          <a:noFill/>
+          <a:ln/>
+        </p:spPr>
+        <p:txBody>
+          <a:bodyPr wrap="square" lIns="0" tIns="0" rIns="0" bIns="0" rtlCol="0" anchor="ctr"/>
+          <a:lstStyle/>
+          <a:p>
+            <a:pPr indent="0" marL="0">
+              <a:buNone/>
+            </a:pPr>
+            <a:r>
+              <a:rPr lang="en-US" sz="1800" dirty="0">
+                <a:solidFill>
+                  <a:srgbClr val="EFEFF1"/>
+                </a:solidFill>
+                <a:latin typeface="Arial" pitchFamily="34" charset="0"/>
+                <a:ea typeface="Arial" pitchFamily="34" charset="-122"/>
+                <a:cs typeface="Arial" pitchFamily="34" charset="-120"/>
+              </a:rPr>
+              <a:t>Confirm AMER WIDGET-A with warehouse — or cut the line.</a:t>
+            </a:r>
+            <a:endParaRPr lang="en-US" sz="1800" dirty="0"/>
+          </a:p>
+        </p:txBody>
+      </p:sp>
+      <p:sp>
+        <p:nvSpPr>
+          <p:cNvPr id="8" name="Shape 6"/>
+          <p:cNvSpPr/>
+          <p:nvPr/>
+        </p:nvSpPr>
+        <p:spPr>
+          <a:xfrm>
+            <a:off x="731520" y="2468880"/>
+            <a:ext cx="10698480" cy="914400"/>
+          </a:xfrm>
+          <a:prstGeom prst="roundRect">
+            <a:avLst>
+              <a:gd name="adj" fmla="val 8000"/>
+            </a:avLst>
+          </a:prstGeom>
+          <a:solidFill>
+            <a:srgbClr val="242427"/>
+          </a:solidFill>
+          <a:ln w="12700">
+            <a:solidFill>
+              <a:srgbClr val="3A3A40"/>
+            </a:solidFill>
+            <a:prstDash val="solid"/>
+          </a:ln>
+        </p:spPr>
+      </p:sp>
+      <p:sp>
+        <p:nvSpPr>
+          <p:cNvPr id="9" name="Shape 7"/>
+          <p:cNvSpPr/>
+          <p:nvPr/>
+        </p:nvSpPr>
+        <p:spPr>
+          <a:xfrm>
+            <a:off x="960120" y="2724912"/>
+            <a:ext cx="402336" cy="402336"/>
+          </a:xfrm>
+          <a:prstGeom prst="ellipse">
+            <a:avLst/>
+          </a:prstGeom>
+          <a:solidFill>
+            <a:srgbClr val="B7AAF3"/>
+          </a:solidFill>
+          <a:ln/>
+        </p:spPr>
+      </p:sp>
+      <p:sp>
+        <p:nvSpPr>
+          <p:cNvPr id="10" name="Text 8"/>
+          <p:cNvSpPr/>
+          <p:nvPr/>
+        </p:nvSpPr>
+        <p:spPr>
+          <a:xfrm>
+            <a:off x="960120" y="2724912"/>
+            <a:ext cx="402336" cy="402336"/>
+          </a:xfrm>
+          <a:prstGeom prst="rect">
+            <a:avLst/>
+          </a:prstGeom>
+          <a:noFill/>
+          <a:ln/>
+        </p:spPr>
+        <p:txBody>
+          <a:bodyPr wrap="square" lIns="0" tIns="0" rIns="0" bIns="0" rtlCol="0" anchor="ctr"/>
+          <a:lstStyle/>
+          <a:p>
+            <a:pPr algn="ctr" indent="0" marL="0">
+              <a:buNone/>
+            </a:pPr>
+            <a:r>
+              <a:rPr lang="en-US" sz="1400" b="1" dirty="0">
+                <a:solidFill>
+                  <a:srgbClr val="141416"/>
+                </a:solidFill>
+                <a:latin typeface="Arial" pitchFamily="34" charset="0"/>
+                <a:ea typeface="Arial" pitchFamily="34" charset="-122"/>
+                <a:cs typeface="Arial" pitchFamily="34" charset="-120"/>
+              </a:rPr>
+              <a:t>2</a:t>
+            </a:r>
+            <a:endParaRPr lang="en-US" sz="1400" dirty="0"/>
+          </a:p>
+        </p:txBody>
+      </p:sp>
+      <p:sp>
+        <p:nvSpPr>
+          <p:cNvPr id="11" name="Text 9"/>
+          <p:cNvSpPr/>
+          <p:nvPr/>
+        </p:nvSpPr>
+        <p:spPr>
+          <a:xfrm>
+            <a:off x="1554480" y="2670048"/>
+            <a:ext cx="9509760" cy="512064"/>
+          </a:xfrm>
+          <a:prstGeom prst="rect">
+            <a:avLst/>
+          </a:prstGeom>
+          <a:noFill/>
+          <a:ln/>
+        </p:spPr>
+        <p:txBody>
+          <a:bodyPr wrap="square" lIns="0" tIns="0" rIns="0" bIns="0" rtlCol="0" anchor="ctr"/>
+          <a:lstStyle/>
+          <a:p>
+            <a:pPr indent="0" marL="0">
+              <a:buNone/>
+            </a:pPr>
+            <a:r>
+              <a:rPr lang="en-US" sz="1800" dirty="0">
+                <a:solidFill>
+                  <a:srgbClr val="EFEFF1"/>
+                </a:solidFill>
+                <a:latin typeface="Arial" pitchFamily="34" charset="0"/>
+                <a:ea typeface="Arial" pitchFamily="34" charset="-122"/>
+                <a:cs typeface="Arial" pitchFamily="34" charset="-120"/>
+              </a:rPr>
+              <a:t>EMEA: expedite 22 units, else drop WIDGET-C from the target.</a:t>
+            </a:r>
+            <a:endParaRPr lang="en-US" sz="1800" dirty="0"/>
+          </a:p>
+        </p:txBody>
+      </p:sp>
+      <p:sp>
+        <p:nvSpPr>
+          <p:cNvPr id="12" name="Shape 10"/>
+          <p:cNvSpPr/>
+          <p:nvPr/>
+        </p:nvSpPr>
+        <p:spPr>
+          <a:xfrm>
+            <a:off x="731520" y="3566160"/>
+            <a:ext cx="10698480" cy="914400"/>
+          </a:xfrm>
+          <a:prstGeom prst="roundRect">
+            <a:avLst>
+              <a:gd name="adj" fmla="val 8000"/>
+            </a:avLst>
+          </a:prstGeom>
+          <a:solidFill>
+            <a:srgbClr val="242427"/>
+          </a:solidFill>
+          <a:ln w="12700">
+            <a:solidFill>
+              <a:srgbClr val="3A3A40"/>
+            </a:solidFill>
+            <a:prstDash val="solid"/>
+          </a:ln>
+        </p:spPr>
+      </p:sp>
+      <p:sp>
+        <p:nvSpPr>
+          <p:cNvPr id="13" name="Shape 11"/>
+          <p:cNvSpPr/>
+          <p:nvPr/>
+        </p:nvSpPr>
+        <p:spPr>
+          <a:xfrm>
+            <a:off x="960120" y="3822192"/>
+            <a:ext cx="402336" cy="402336"/>
+          </a:xfrm>
+          <a:prstGeom prst="ellipse">
+            <a:avLst/>
+          </a:prstGeom>
+          <a:solidFill>
+            <a:srgbClr val="B7AAF3"/>
+          </a:solidFill>
+          <a:ln/>
+        </p:spPr>
+      </p:sp>
+      <p:sp>
+        <p:nvSpPr>
+          <p:cNvPr id="14" name="Text 12"/>
+          <p:cNvSpPr/>
+          <p:nvPr/>
+        </p:nvSpPr>
+        <p:spPr>
+          <a:xfrm>
+            <a:off x="960120" y="3822192"/>
+            <a:ext cx="402336" cy="402336"/>
+          </a:xfrm>
+          <a:prstGeom prst="rect">
+            <a:avLst/>
+          </a:prstGeom>
+          <a:noFill/>
+          <a:ln/>
+        </p:spPr>
+        <p:txBody>
+          <a:bodyPr wrap="square" lIns="0" tIns="0" rIns="0" bIns="0" rtlCol="0" anchor="ctr"/>
+          <a:lstStyle/>
+          <a:p>
+            <a:pPr algn="ctr" indent="0" marL="0">
+              <a:buNone/>
+            </a:pPr>
+            <a:r>
+              <a:rPr lang="en-US" sz="1400" b="1" dirty="0">
+                <a:solidFill>
+                  <a:srgbClr val="141416"/>
+                </a:solidFill>
+                <a:latin typeface="Arial" pitchFamily="34" charset="0"/>
+                <a:ea typeface="Arial" pitchFamily="34" charset="-122"/>
+                <a:cs typeface="Arial" pitchFamily="34" charset="-120"/>
+              </a:rPr>
+              <a:t>3</a:t>
+            </a:r>
+            <a:endParaRPr lang="en-US" sz="1400" dirty="0"/>
+          </a:p>
+        </p:txBody>
+      </p:sp>
+      <p:sp>
+        <p:nvSpPr>
+          <p:cNvPr id="15" name="Text 13"/>
+          <p:cNvSpPr/>
+          <p:nvPr/>
+        </p:nvSpPr>
+        <p:spPr>
+          <a:xfrm>
+            <a:off x="1554480" y="3767328"/>
+            <a:ext cx="9509760" cy="512064"/>
+          </a:xfrm>
+          <a:prstGeom prst="rect">
+            <a:avLst/>
+          </a:prstGeom>
+          <a:noFill/>
+          <a:ln/>
+        </p:spPr>
+        <p:txBody>
+          <a:bodyPr wrap="square" lIns="0" tIns="0" rIns="0" bIns="0" rtlCol="0" anchor="ctr"/>
+          <a:lstStyle/>
+          <a:p>
+            <a:pPr indent="0" marL="0">
+              <a:buNone/>
+            </a:pPr>
+            <a:r>
+              <a:rPr lang="en-US" sz="1800" dirty="0">
+                <a:solidFill>
+                  <a:srgbClr val="EFEFF1"/>
+                </a:solidFill>
+                <a:latin typeface="Arial" pitchFamily="34" charset="0"/>
+                <a:ea typeface="Arial" pitchFamily="34" charset="-122"/>
+                <a:cs typeface="Arial" pitchFamily="34" charset="-120"/>
+              </a:rPr>
+              <a:t>Rebuild the region × SKU sheet without cancelled rows.</a:t>
+            </a:r>
+            <a:endParaRPr lang="en-US" sz="1800" dirty="0"/>
+          </a:p>
+        </p:txBody>
+      </p:sp>
+      <p:sp>
+        <p:nvSpPr>
+          <p:cNvPr id="16" name="Shape 14"/>
+          <p:cNvSpPr/>
+          <p:nvPr/>
+        </p:nvSpPr>
+        <p:spPr>
+          <a:xfrm>
+            <a:off x="731520" y="4663440"/>
+            <a:ext cx="10698480" cy="914400"/>
+          </a:xfrm>
+          <a:prstGeom prst="roundRect">
+            <a:avLst>
+              <a:gd name="adj" fmla="val 8000"/>
+            </a:avLst>
+          </a:prstGeom>
+          <a:solidFill>
+            <a:srgbClr val="242427"/>
+          </a:solidFill>
+          <a:ln w="12700">
+            <a:solidFill>
+              <a:srgbClr val="3A3A40"/>
+            </a:solidFill>
+            <a:prstDash val="solid"/>
+          </a:ln>
+        </p:spPr>
+      </p:sp>
+      <p:sp>
+        <p:nvSpPr>
+          <p:cNvPr id="17" name="Shape 15"/>
+          <p:cNvSpPr/>
+          <p:nvPr/>
+        </p:nvSpPr>
+        <p:spPr>
+          <a:xfrm>
+            <a:off x="960120" y="4919472"/>
+            <a:ext cx="402336" cy="402336"/>
+          </a:xfrm>
+          <a:prstGeom prst="ellipse">
+            <a:avLst/>
+          </a:prstGeom>
+          <a:solidFill>
+            <a:srgbClr val="B7AAF3"/>
+          </a:solidFill>
+          <a:ln/>
+        </p:spPr>
+      </p:sp>
+      <p:sp>
+        <p:nvSpPr>
+          <p:cNvPr id="18" name="Text 16"/>
+          <p:cNvSpPr/>
+          <p:nvPr/>
+        </p:nvSpPr>
+        <p:spPr>
+          <a:xfrm>
+            <a:off x="960120" y="4919472"/>
+            <a:ext cx="402336" cy="402336"/>
+          </a:xfrm>
+          <a:prstGeom prst="rect">
+            <a:avLst/>
+          </a:prstGeom>
+          <a:noFill/>
+          <a:ln/>
+        </p:spPr>
+        <p:txBody>
+          <a:bodyPr wrap="square" lIns="0" tIns="0" rIns="0" bIns="0" rtlCol="0" anchor="ctr"/>
+          <a:lstStyle/>
+          <a:p>
+            <a:pPr algn="ctr" indent="0" marL="0">
+              <a:buNone/>
+            </a:pPr>
+            <a:r>
+              <a:rPr lang="en-US" sz="1400" b="1" dirty="0">
+                <a:solidFill>
+                  <a:srgbClr val="141416"/>
+                </a:solidFill>
+                <a:latin typeface="Arial" pitchFamily="34" charset="0"/>
+                <a:ea typeface="Arial" pitchFamily="34" charset="-122"/>
+                <a:cs typeface="Arial" pitchFamily="34" charset="-120"/>
+              </a:rPr>
+              <a:t>4</a:t>
+            </a:r>
+            <a:endParaRPr lang="en-US" sz="1400" dirty="0"/>
+          </a:p>
+        </p:txBody>
+      </p:sp>
+      <p:sp>
+        <p:nvSpPr>
+          <p:cNvPr id="19" name="Text 17"/>
+          <p:cNvSpPr/>
+          <p:nvPr/>
+        </p:nvSpPr>
+        <p:spPr>
+          <a:xfrm>
+            <a:off x="1554480" y="4864608"/>
+            <a:ext cx="9509760" cy="512064"/>
+          </a:xfrm>
+          <a:prstGeom prst="rect">
+            <a:avLst/>
+          </a:prstGeom>
+          <a:noFill/>
+          <a:ln/>
+        </p:spPr>
+        <p:txBody>
+          <a:bodyPr wrap="square" lIns="0" tIns="0" rIns="0" bIns="0" rtlCol="0" anchor="ctr"/>
+          <a:lstStyle/>
+          <a:p>
+            <a:pPr indent="0" marL="0">
+              <a:buNone/>
+            </a:pPr>
+            <a:r>
+              <a:rPr lang="en-US" sz="1800" dirty="0">
+                <a:solidFill>
+                  <a:srgbClr val="EFEFF1"/>
+                </a:solidFill>
+                <a:latin typeface="Arial" pitchFamily="34" charset="0"/>
+                <a:ea typeface="Arial" pitchFamily="34" charset="-122"/>
+                <a:cs typeface="Arial" pitchFamily="34" charset="-120"/>
+              </a:rPr>
+              <a:t>One-page PDF for stand-up; deck stays the source of truth.</a:t>
+            </a:r>
+            <a:endParaRPr lang="en-US" sz="1800" dirty="0"/>
           </a:p>
         </p:txBody>
       </p:sp>

</xml_diff>